<commit_message>
Guard PDF evidence fidelity and deliver verified demo and submission package
</commit_message>
<xml_diff>
--- a/output/presentation/batchlight-pitch.pptx
+++ b/output/presentation/batchlight-pitch.pptx
@@ -2,21 +2,21 @@
 <file path=ppt/presentation.xml><?xml version="1.0" encoding="utf-8"?>
 <p:presentation xmlns:p="http://schemas.openxmlformats.org/presentationml/2006/main">
   <p:sldMasterIdLst>
-    <p:sldMasterId xmlns:r="http://schemas.openxmlformats.org/officeDocument/2006/relationships" id="2147483648" r:id="R026ef59ee6074792"/>
+    <p:sldMasterId xmlns:r="http://schemas.openxmlformats.org/officeDocument/2006/relationships" id="2147483648" r:id="R5261021ca0e846da"/>
   </p:sldMasterIdLst>
   <p:notesMasterIdLst>
-    <p:notesMasterId xmlns:r="http://schemas.openxmlformats.org/officeDocument/2006/relationships" r:id="R2fc244f02b654b02"/>
+    <p:notesMasterId xmlns:r="http://schemas.openxmlformats.org/officeDocument/2006/relationships" r:id="Rf463c03c057e4423"/>
   </p:notesMasterIdLst>
   <p:sldIdLst>
-    <p:sldId xmlns:r="http://schemas.openxmlformats.org/officeDocument/2006/relationships" id="256" r:id="R3e01d4da45034c2d"/>
-    <p:sldId xmlns:r="http://schemas.openxmlformats.org/officeDocument/2006/relationships" id="257" r:id="R933e15d476174e31"/>
-    <p:sldId xmlns:r="http://schemas.openxmlformats.org/officeDocument/2006/relationships" id="258" r:id="R817c838217394966"/>
-    <p:sldId xmlns:r="http://schemas.openxmlformats.org/officeDocument/2006/relationships" id="259" r:id="R8cf39b530cf74f82"/>
-    <p:sldId xmlns:r="http://schemas.openxmlformats.org/officeDocument/2006/relationships" id="260" r:id="R43f25e1508b247bd"/>
-    <p:sldId xmlns:r="http://schemas.openxmlformats.org/officeDocument/2006/relationships" id="261" r:id="R7866b7db80d54a92"/>
-    <p:sldId xmlns:r="http://schemas.openxmlformats.org/officeDocument/2006/relationships" id="262" r:id="Rd8fbddb6292442cc"/>
-    <p:sldId xmlns:r="http://schemas.openxmlformats.org/officeDocument/2006/relationships" id="263" r:id="R147bb79d3ee242d3"/>
-    <p:sldId xmlns:r="http://schemas.openxmlformats.org/officeDocument/2006/relationships" id="264" r:id="R5b504eedd1c7460c"/>
+    <p:sldId xmlns:r="http://schemas.openxmlformats.org/officeDocument/2006/relationships" id="256" r:id="R5ba48410371d46e7"/>
+    <p:sldId xmlns:r="http://schemas.openxmlformats.org/officeDocument/2006/relationships" id="257" r:id="Rfeb5b63eeed84e9a"/>
+    <p:sldId xmlns:r="http://schemas.openxmlformats.org/officeDocument/2006/relationships" id="258" r:id="R327fd4513ea44385"/>
+    <p:sldId xmlns:r="http://schemas.openxmlformats.org/officeDocument/2006/relationships" id="259" r:id="R5ef2fd50d6164aae"/>
+    <p:sldId xmlns:r="http://schemas.openxmlformats.org/officeDocument/2006/relationships" id="260" r:id="Ra6f8989518bb4283"/>
+    <p:sldId xmlns:r="http://schemas.openxmlformats.org/officeDocument/2006/relationships" id="261" r:id="Rf11521427ec545a1"/>
+    <p:sldId xmlns:r="http://schemas.openxmlformats.org/officeDocument/2006/relationships" id="262" r:id="R92cd252419b34711"/>
+    <p:sldId xmlns:r="http://schemas.openxmlformats.org/officeDocument/2006/relationships" id="263" r:id="R75344edff5a8400e"/>
+    <p:sldId xmlns:r="http://schemas.openxmlformats.org/officeDocument/2006/relationships" id="264" r:id="Rbb0bfbbafb4d4307"/>
   </p:sldIdLst>
   <p:sldSz cx="12192000" cy="6858000"/>
   <p:notesSz cx="6858000" cy="9144000"/>
@@ -1078,7 +1078,7 @@
   </p:cSld>
   <p:clrMap bg1="lt1" tx1="dk1" bg2="lt2" tx2="dk2" accent1="accent1" accent2="accent2" accent3="accent3" accent4="accent4" accent5="accent5" accent6="accent6" hlink="hlink" folHlink="folHlink"/>
   <p:sldLayoutIdLst>
-    <p:sldLayoutId xmlns:r="http://schemas.openxmlformats.org/officeDocument/2006/relationships" id="2147483649" r:id="R94c2482bff714ab2"/>
+    <p:sldLayoutId xmlns:r="http://schemas.openxmlformats.org/officeDocument/2006/relationships" id="2147483649" r:id="R0be1e4bcd41f4b40"/>
   </p:sldLayoutIdLst>
   <p:txStyles>
     <p:titleStyle>
@@ -1629,7 +1629,7 @@
           <p:cNvPr id="7" name="">
             <a:extLst xmlns:a="http://schemas.openxmlformats.org/drawingml/2006/main">
               <a:ext uri="{FF2B5EF4-FFF2-40B4-BE49-F238E27FC236}">
-                <a16:creationId xmlns:a16="http://schemas.microsoft.com/office/drawing/2014/main" id="{F7789346-B4E4-4F39-880C-B1032AF275DF}"/>
+                <a16:creationId xmlns:a16="http://schemas.microsoft.com/office/drawing/2014/main" id="{04548FAD-7EA7-4FD1-A147-1DA944261314}"/>
               </a:ext>
             </a:extLst>
           </p:cNvPr>
@@ -1686,7 +1686,7 @@
           <p:cNvPr id="2" name="">
             <a:extLst xmlns:a="http://schemas.openxmlformats.org/drawingml/2006/main">
               <a:ext uri="{FF2B5EF4-FFF2-40B4-BE49-F238E27FC236}">
-                <a16:creationId xmlns:a16="http://schemas.microsoft.com/office/drawing/2014/main" id="{83286BF3-CA54-4891-81EC-EAB947D25514}"/>
+                <a16:creationId xmlns:a16="http://schemas.microsoft.com/office/drawing/2014/main" id="{08ACD889-EDED-4F8F-A05F-48D866888569}"/>
               </a:ext>
             </a:extLst>
           </p:cNvPr>
@@ -1743,7 +1743,7 @@
           <p:cNvPr id="3" name="">
             <a:extLst xmlns:a="http://schemas.openxmlformats.org/drawingml/2006/main">
               <a:ext uri="{FF2B5EF4-FFF2-40B4-BE49-F238E27FC236}">
-                <a16:creationId xmlns:a16="http://schemas.microsoft.com/office/drawing/2014/main" id="{F55C912A-36E9-4F71-A8A6-0326FC166190}"/>
+                <a16:creationId xmlns:a16="http://schemas.microsoft.com/office/drawing/2014/main" id="{573C6288-C59B-44BC-AAD4-930E44648794}"/>
               </a:ext>
             </a:extLst>
           </p:cNvPr>
@@ -1800,7 +1800,7 @@
           <p:cNvPr id="4" name="">
             <a:extLst xmlns:a="http://schemas.openxmlformats.org/drawingml/2006/main">
               <a:ext uri="{FF2B5EF4-FFF2-40B4-BE49-F238E27FC236}">
-                <a16:creationId xmlns:a16="http://schemas.microsoft.com/office/drawing/2014/main" id="{B31C581F-85E8-49FE-80F5-A06960D88D50}"/>
+                <a16:creationId xmlns:a16="http://schemas.microsoft.com/office/drawing/2014/main" id="{39373614-1A6C-4DEA-B1DF-E31729729BE8}"/>
               </a:ext>
             </a:extLst>
           </p:cNvPr>
@@ -1857,7 +1857,7 @@
           <p:cNvPr id="5" name="">
             <a:extLst xmlns:a="http://schemas.openxmlformats.org/drawingml/2006/main">
               <a:ext uri="{FF2B5EF4-FFF2-40B4-BE49-F238E27FC236}">
-                <a16:creationId xmlns:a16="http://schemas.microsoft.com/office/drawing/2014/main" id="{5C9043BF-58B2-4AFC-A98F-54C29C8996D3}"/>
+                <a16:creationId xmlns:a16="http://schemas.microsoft.com/office/drawing/2014/main" id="{2F9A0D1C-89ED-4C60-830A-EFE13B8F545A}"/>
               </a:ext>
             </a:extLst>
           </p:cNvPr>
@@ -1937,7 +1937,7 @@
           <p:cNvPr id="6" name="">
             <a:extLst xmlns:a="http://schemas.openxmlformats.org/drawingml/2006/main">
               <a:ext uri="{FF2B5EF4-FFF2-40B4-BE49-F238E27FC236}">
-                <a16:creationId xmlns:a16="http://schemas.microsoft.com/office/drawing/2014/main" id="{0E2E9E32-A28D-4239-9AB8-8EC5E79D087F}"/>
+                <a16:creationId xmlns:a16="http://schemas.microsoft.com/office/drawing/2014/main" id="{3EFD0DE1-7920-45D8-92EA-685E13D063D2}"/>
               </a:ext>
             </a:extLst>
           </p:cNvPr>
@@ -1992,7 +1992,7 @@
     </p:spTree>
     <p:extLst>
       <p:ext uri="{BB962C8B-B14F-4D97-AF65-F5344CB8AC3E}">
-        <p14:creationId xmlns:p14="http://schemas.microsoft.com/office/powerpoint/2010/main" val="389576029"/>
+        <p14:creationId xmlns:p14="http://schemas.microsoft.com/office/powerpoint/2010/main" val="1897998182"/>
       </p:ext>
     </p:extLst>
   </p:cSld>
@@ -2023,7 +2023,7 @@
           <p:cNvPr id="8" name="">
             <a:extLst xmlns:a="http://schemas.openxmlformats.org/drawingml/2006/main">
               <a:ext uri="{FF2B5EF4-FFF2-40B4-BE49-F238E27FC236}">
-                <a16:creationId xmlns:a16="http://schemas.microsoft.com/office/drawing/2014/main" id="{7FB12B87-4440-4FDA-885E-15F6A7D417B3}"/>
+                <a16:creationId xmlns:a16="http://schemas.microsoft.com/office/drawing/2014/main" id="{1DACE8D8-07F8-4379-8300-B30DC7DE1D32}"/>
               </a:ext>
             </a:extLst>
           </p:cNvPr>
@@ -2080,7 +2080,7 @@
           <p:cNvPr id="2" name="">
             <a:extLst xmlns:a="http://schemas.openxmlformats.org/drawingml/2006/main">
               <a:ext uri="{FF2B5EF4-FFF2-40B4-BE49-F238E27FC236}">
-                <a16:creationId xmlns:a16="http://schemas.microsoft.com/office/drawing/2014/main" id="{EB5CFF1B-CA87-4176-A5F5-3E22395EB6D0}"/>
+                <a16:creationId xmlns:a16="http://schemas.microsoft.com/office/drawing/2014/main" id="{2D19AD29-B00F-4C73-A82D-632C93789F2F}"/>
               </a:ext>
             </a:extLst>
           </p:cNvPr>
@@ -2137,7 +2137,7 @@
           <p:cNvPr id="3" name="">
             <a:extLst xmlns:a="http://schemas.openxmlformats.org/drawingml/2006/main">
               <a:ext uri="{FF2B5EF4-FFF2-40B4-BE49-F238E27FC236}">
-                <a16:creationId xmlns:a16="http://schemas.microsoft.com/office/drawing/2014/main" id="{CF89B543-F97D-427A-A328-4710A73B9DEA}"/>
+                <a16:creationId xmlns:a16="http://schemas.microsoft.com/office/drawing/2014/main" id="{C528ABFD-E3C5-4B01-B8E2-0337B5999FD4}"/>
               </a:ext>
             </a:extLst>
           </p:cNvPr>
@@ -2194,7 +2194,7 @@
           <p:cNvPr id="4" name="">
             <a:extLst xmlns:a="http://schemas.openxmlformats.org/drawingml/2006/main">
               <a:ext uri="{FF2B5EF4-FFF2-40B4-BE49-F238E27FC236}">
-                <a16:creationId xmlns:a16="http://schemas.microsoft.com/office/drawing/2014/main" id="{74391598-01A7-43DD-991A-C83318891A75}"/>
+                <a16:creationId xmlns:a16="http://schemas.microsoft.com/office/drawing/2014/main" id="{1107BEC5-8B01-4EBF-86AE-05E8FE677AC5}"/>
               </a:ext>
             </a:extLst>
           </p:cNvPr>
@@ -2251,7 +2251,7 @@
           <p:cNvPr id="5" name="">
             <a:extLst xmlns:a="http://schemas.openxmlformats.org/drawingml/2006/main">
               <a:ext uri="{FF2B5EF4-FFF2-40B4-BE49-F238E27FC236}">
-                <a16:creationId xmlns:a16="http://schemas.microsoft.com/office/drawing/2014/main" id="{5F384ADD-0590-4475-8AE8-63C75AABCA9F}"/>
+                <a16:creationId xmlns:a16="http://schemas.microsoft.com/office/drawing/2014/main" id="{35CFF7F7-23DA-4FFD-884D-E0F25F1431EA}"/>
               </a:ext>
             </a:extLst>
           </p:cNvPr>
@@ -2331,7 +2331,7 @@
           <p:cNvPr id="6" name="">
             <a:extLst xmlns:a="http://schemas.openxmlformats.org/drawingml/2006/main">
               <a:ext uri="{FF2B5EF4-FFF2-40B4-BE49-F238E27FC236}">
-                <a16:creationId xmlns:a16="http://schemas.microsoft.com/office/drawing/2014/main" id="{8787BDD1-5413-4B3F-8C0A-FFE1A61B46A4}"/>
+                <a16:creationId xmlns:a16="http://schemas.microsoft.com/office/drawing/2014/main" id="{4441F94B-7371-412B-9EB7-87B28C16B0AA}"/>
               </a:ext>
             </a:extLst>
           </p:cNvPr>
@@ -2388,7 +2388,7 @@
           <p:cNvPr id="7" name="">
             <a:extLst xmlns:a="http://schemas.openxmlformats.org/drawingml/2006/main">
               <a:ext uri="{FF2B5EF4-FFF2-40B4-BE49-F238E27FC236}">
-                <a16:creationId xmlns:a16="http://schemas.microsoft.com/office/drawing/2014/main" id="{31297B88-37FC-49F3-956D-CFB4EFDA03CC}"/>
+                <a16:creationId xmlns:a16="http://schemas.microsoft.com/office/drawing/2014/main" id="{B484B553-C64A-45FF-B8AF-291883583CBD}"/>
               </a:ext>
             </a:extLst>
           </p:cNvPr>
@@ -2443,7 +2443,7 @@
     </p:spTree>
     <p:extLst>
       <p:ext uri="{BB962C8B-B14F-4D97-AF65-F5344CB8AC3E}">
-        <p14:creationId xmlns:p14="http://schemas.microsoft.com/office/powerpoint/2010/main" val="784318592"/>
+        <p14:creationId xmlns:p14="http://schemas.microsoft.com/office/powerpoint/2010/main" val="1142564819"/>
       </p:ext>
     </p:extLst>
   </p:cSld>
@@ -2474,7 +2474,7 @@
           <p:cNvPr id="6" name="">
             <a:extLst xmlns:a="http://schemas.openxmlformats.org/drawingml/2006/main">
               <a:ext uri="{FF2B5EF4-FFF2-40B4-BE49-F238E27FC236}">
-                <a16:creationId xmlns:a16="http://schemas.microsoft.com/office/drawing/2014/main" id="{43A49265-EA2A-496C-9C20-D8A4EA3E25D5}"/>
+                <a16:creationId xmlns:a16="http://schemas.microsoft.com/office/drawing/2014/main" id="{5E71BAC4-D45D-4C87-9C17-68315A676F66}"/>
               </a:ext>
             </a:extLst>
           </p:cNvPr>
@@ -2531,7 +2531,7 @@
           <p:cNvPr id="2" name="">
             <a:extLst xmlns:a="http://schemas.openxmlformats.org/drawingml/2006/main">
               <a:ext uri="{FF2B5EF4-FFF2-40B4-BE49-F238E27FC236}">
-                <a16:creationId xmlns:a16="http://schemas.microsoft.com/office/drawing/2014/main" id="{CD2B21CD-1BEB-42AF-A66A-4146F8046B7B}"/>
+                <a16:creationId xmlns:a16="http://schemas.microsoft.com/office/drawing/2014/main" id="{33A16017-1CF5-465F-810C-7B1C180CC5CF}"/>
               </a:ext>
             </a:extLst>
           </p:cNvPr>
@@ -2588,7 +2588,7 @@
           <p:cNvPr id="3" name="">
             <a:extLst xmlns:a="http://schemas.openxmlformats.org/drawingml/2006/main">
               <a:ext uri="{FF2B5EF4-FFF2-40B4-BE49-F238E27FC236}">
-                <a16:creationId xmlns:a16="http://schemas.microsoft.com/office/drawing/2014/main" id="{214E7D84-403C-4FB5-836A-8C176048C941}"/>
+                <a16:creationId xmlns:a16="http://schemas.microsoft.com/office/drawing/2014/main" id="{25654AEE-9532-4275-8946-66D1174C7574}"/>
               </a:ext>
             </a:extLst>
           </p:cNvPr>
@@ -2649,7 +2649,7 @@
           <p:nvPr/>
         </p:nvPicPr>
         <p:blipFill>
-          <a:blip xmlns:r="http://schemas.openxmlformats.org/officeDocument/2006/relationships" xmlns:a="http://schemas.openxmlformats.org/drawingml/2006/main" r:embed="R18a5b0c89c874d08"/>
+          <a:blip xmlns:r="http://schemas.openxmlformats.org/officeDocument/2006/relationships" xmlns:a="http://schemas.openxmlformats.org/drawingml/2006/main" r:embed="Redf3351587b44888"/>
           <a:stretch xmlns:a="http://schemas.openxmlformats.org/drawingml/2006/main"/>
         </p:blipFill>
         <p:spPr>
@@ -2667,7 +2667,7 @@
           <p:cNvPr id="5" name="">
             <a:extLst xmlns:a="http://schemas.openxmlformats.org/drawingml/2006/main">
               <a:ext uri="{FF2B5EF4-FFF2-40B4-BE49-F238E27FC236}">
-                <a16:creationId xmlns:a16="http://schemas.microsoft.com/office/drawing/2014/main" id="{38301A4F-BF10-443E-B2C9-ED9E33FE94CA}"/>
+                <a16:creationId xmlns:a16="http://schemas.microsoft.com/office/drawing/2014/main" id="{35644A6D-11B8-463F-84B2-047FFA2739C6}"/>
               </a:ext>
             </a:extLst>
           </p:cNvPr>
@@ -2722,7 +2722,7 @@
     </p:spTree>
     <p:extLst>
       <p:ext uri="{BB962C8B-B14F-4D97-AF65-F5344CB8AC3E}">
-        <p14:creationId xmlns:p14="http://schemas.microsoft.com/office/powerpoint/2010/main" val="2071847300"/>
+        <p14:creationId xmlns:p14="http://schemas.microsoft.com/office/powerpoint/2010/main" val="660725028"/>
       </p:ext>
     </p:extLst>
   </p:cSld>
@@ -2753,7 +2753,7 @@
           <p:cNvPr id="14" name="">
             <a:extLst xmlns:a="http://schemas.openxmlformats.org/drawingml/2006/main">
               <a:ext uri="{FF2B5EF4-FFF2-40B4-BE49-F238E27FC236}">
-                <a16:creationId xmlns:a16="http://schemas.microsoft.com/office/drawing/2014/main" id="{76446641-3868-4CBD-8ACD-0E8577E66A0D}"/>
+                <a16:creationId xmlns:a16="http://schemas.microsoft.com/office/drawing/2014/main" id="{FA61D302-387D-4C64-8C0A-D06AE5D534AE}"/>
               </a:ext>
             </a:extLst>
           </p:cNvPr>
@@ -2810,7 +2810,7 @@
           <p:cNvPr id="2" name="">
             <a:extLst xmlns:a="http://schemas.openxmlformats.org/drawingml/2006/main">
               <a:ext uri="{FF2B5EF4-FFF2-40B4-BE49-F238E27FC236}">
-                <a16:creationId xmlns:a16="http://schemas.microsoft.com/office/drawing/2014/main" id="{C72B96BB-B428-4BCB-8898-882E2437FAB7}"/>
+                <a16:creationId xmlns:a16="http://schemas.microsoft.com/office/drawing/2014/main" id="{7128B8D7-62F6-4B26-A700-1AD700EC01F0}"/>
               </a:ext>
             </a:extLst>
           </p:cNvPr>
@@ -2867,7 +2867,7 @@
           <p:cNvPr id="3" name="">
             <a:extLst xmlns:a="http://schemas.openxmlformats.org/drawingml/2006/main">
               <a:ext uri="{FF2B5EF4-FFF2-40B4-BE49-F238E27FC236}">
-                <a16:creationId xmlns:a16="http://schemas.microsoft.com/office/drawing/2014/main" id="{B2C176D8-0B03-4697-9610-BCFD37B6F6E0}"/>
+                <a16:creationId xmlns:a16="http://schemas.microsoft.com/office/drawing/2014/main" id="{65F7C83E-DCAE-4E01-A3C5-A599AE8F9BBA}"/>
               </a:ext>
             </a:extLst>
           </p:cNvPr>
@@ -2924,7 +2924,7 @@
           <p:cNvPr id="4" name="">
             <a:extLst xmlns:a="http://schemas.openxmlformats.org/drawingml/2006/main">
               <a:ext uri="{FF2B5EF4-FFF2-40B4-BE49-F238E27FC236}">
-                <a16:creationId xmlns:a16="http://schemas.microsoft.com/office/drawing/2014/main" id="{435289CD-8531-4161-A2A7-2C2C6B0A87BC}"/>
+                <a16:creationId xmlns:a16="http://schemas.microsoft.com/office/drawing/2014/main" id="{E893927C-5E85-4C09-9EA0-4605B9335628}"/>
               </a:ext>
             </a:extLst>
           </p:cNvPr>
@@ -2981,7 +2981,7 @@
           <p:cNvPr id="5" name="">
             <a:extLst xmlns:a="http://schemas.openxmlformats.org/drawingml/2006/main">
               <a:ext uri="{FF2B5EF4-FFF2-40B4-BE49-F238E27FC236}">
-                <a16:creationId xmlns:a16="http://schemas.microsoft.com/office/drawing/2014/main" id="{F2527D34-454B-4B04-8423-AD49AEBBEB61}"/>
+                <a16:creationId xmlns:a16="http://schemas.microsoft.com/office/drawing/2014/main" id="{92B0C32A-4C5B-4518-95D5-1EB9EF88AB24}"/>
               </a:ext>
             </a:extLst>
           </p:cNvPr>
@@ -3038,7 +3038,7 @@
           <p:cNvPr id="6" name="">
             <a:extLst xmlns:a="http://schemas.openxmlformats.org/drawingml/2006/main">
               <a:ext uri="{FF2B5EF4-FFF2-40B4-BE49-F238E27FC236}">
-                <a16:creationId xmlns:a16="http://schemas.microsoft.com/office/drawing/2014/main" id="{85424C70-4700-41C6-AEFE-4B58B45C37F6}"/>
+                <a16:creationId xmlns:a16="http://schemas.microsoft.com/office/drawing/2014/main" id="{65B7D857-28CB-4044-A4FB-CD259E9EDA14}"/>
               </a:ext>
             </a:extLst>
           </p:cNvPr>
@@ -3095,7 +3095,7 @@
           <p:cNvPr id="7" name="">
             <a:extLst xmlns:a="http://schemas.openxmlformats.org/drawingml/2006/main">
               <a:ext uri="{FF2B5EF4-FFF2-40B4-BE49-F238E27FC236}">
-                <a16:creationId xmlns:a16="http://schemas.microsoft.com/office/drawing/2014/main" id="{96C14D02-FEDB-4CBB-910D-574127FCE9E6}"/>
+                <a16:creationId xmlns:a16="http://schemas.microsoft.com/office/drawing/2014/main" id="{788F60C1-6811-4B47-B4FD-F4C8AA35B6D7}"/>
               </a:ext>
             </a:extLst>
           </p:cNvPr>
@@ -3152,7 +3152,7 @@
           <p:cNvPr id="8" name="">
             <a:extLst xmlns:a="http://schemas.openxmlformats.org/drawingml/2006/main">
               <a:ext uri="{FF2B5EF4-FFF2-40B4-BE49-F238E27FC236}">
-                <a16:creationId xmlns:a16="http://schemas.microsoft.com/office/drawing/2014/main" id="{99A91936-0C8D-403B-A266-BB6DB09FDBD7}"/>
+                <a16:creationId xmlns:a16="http://schemas.microsoft.com/office/drawing/2014/main" id="{6B4492DE-0DEC-489E-B145-BC4F7FA103B0}"/>
               </a:ext>
             </a:extLst>
           </p:cNvPr>
@@ -3209,7 +3209,7 @@
           <p:cNvPr id="9" name="">
             <a:extLst xmlns:a="http://schemas.openxmlformats.org/drawingml/2006/main">
               <a:ext uri="{FF2B5EF4-FFF2-40B4-BE49-F238E27FC236}">
-                <a16:creationId xmlns:a16="http://schemas.microsoft.com/office/drawing/2014/main" id="{35E549DE-250D-4D60-9F1A-CBE4AFF0476F}"/>
+                <a16:creationId xmlns:a16="http://schemas.microsoft.com/office/drawing/2014/main" id="{2F0B7A1A-ED9D-43D8-B817-E6BE2DD2C1DF}"/>
               </a:ext>
             </a:extLst>
           </p:cNvPr>
@@ -3266,7 +3266,7 @@
           <p:cNvPr id="10" name="">
             <a:extLst xmlns:a="http://schemas.openxmlformats.org/drawingml/2006/main">
               <a:ext uri="{FF2B5EF4-FFF2-40B4-BE49-F238E27FC236}">
-                <a16:creationId xmlns:a16="http://schemas.microsoft.com/office/drawing/2014/main" id="{9AE03D64-0D63-4E20-AABC-834927351FBA}"/>
+                <a16:creationId xmlns:a16="http://schemas.microsoft.com/office/drawing/2014/main" id="{9BC30E59-AD6E-4AF1-BE93-3B154176DACB}"/>
               </a:ext>
             </a:extLst>
           </p:cNvPr>
@@ -3323,7 +3323,7 @@
           <p:cNvPr id="11" name="">
             <a:extLst xmlns:a="http://schemas.openxmlformats.org/drawingml/2006/main">
               <a:ext uri="{FF2B5EF4-FFF2-40B4-BE49-F238E27FC236}">
-                <a16:creationId xmlns:a16="http://schemas.microsoft.com/office/drawing/2014/main" id="{5045BAC5-71D2-4EBD-B23A-9E301076A61F}"/>
+                <a16:creationId xmlns:a16="http://schemas.microsoft.com/office/drawing/2014/main" id="{6B52294B-77C1-4345-80A2-B09F57065181}"/>
               </a:ext>
             </a:extLst>
           </p:cNvPr>
@@ -3380,7 +3380,7 @@
           <p:cNvPr id="12" name="">
             <a:extLst xmlns:a="http://schemas.openxmlformats.org/drawingml/2006/main">
               <a:ext uri="{FF2B5EF4-FFF2-40B4-BE49-F238E27FC236}">
-                <a16:creationId xmlns:a16="http://schemas.microsoft.com/office/drawing/2014/main" id="{3DE85E05-2374-4935-8956-1AA3320500A6}"/>
+                <a16:creationId xmlns:a16="http://schemas.microsoft.com/office/drawing/2014/main" id="{EB414787-87F2-45B2-9848-38E9BF756887}"/>
               </a:ext>
             </a:extLst>
           </p:cNvPr>
@@ -3437,7 +3437,7 @@
           <p:cNvPr id="13" name="">
             <a:extLst xmlns:a="http://schemas.openxmlformats.org/drawingml/2006/main">
               <a:ext uri="{FF2B5EF4-FFF2-40B4-BE49-F238E27FC236}">
-                <a16:creationId xmlns:a16="http://schemas.microsoft.com/office/drawing/2014/main" id="{1DAFE414-D799-47B9-B343-700451493170}"/>
+                <a16:creationId xmlns:a16="http://schemas.microsoft.com/office/drawing/2014/main" id="{34EC9DC8-F460-48EE-9032-7C835AB41578}"/>
               </a:ext>
             </a:extLst>
           </p:cNvPr>
@@ -3492,7 +3492,7 @@
     </p:spTree>
     <p:extLst>
       <p:ext uri="{BB962C8B-B14F-4D97-AF65-F5344CB8AC3E}">
-        <p14:creationId xmlns:p14="http://schemas.microsoft.com/office/powerpoint/2010/main" val="496261520"/>
+        <p14:creationId xmlns:p14="http://schemas.microsoft.com/office/powerpoint/2010/main" val="83947468"/>
       </p:ext>
     </p:extLst>
   </p:cSld>
@@ -3523,7 +3523,7 @@
           <p:cNvPr id="9" name="">
             <a:extLst xmlns:a="http://schemas.openxmlformats.org/drawingml/2006/main">
               <a:ext uri="{FF2B5EF4-FFF2-40B4-BE49-F238E27FC236}">
-                <a16:creationId xmlns:a16="http://schemas.microsoft.com/office/drawing/2014/main" id="{B38D6C75-2E9D-4804-B37F-045E91A10B32}"/>
+                <a16:creationId xmlns:a16="http://schemas.microsoft.com/office/drawing/2014/main" id="{7FEFD2D6-516D-429D-87DA-72D6FDEAFE30}"/>
               </a:ext>
             </a:extLst>
           </p:cNvPr>
@@ -3580,7 +3580,7 @@
           <p:cNvPr id="2" name="">
             <a:extLst xmlns:a="http://schemas.openxmlformats.org/drawingml/2006/main">
               <a:ext uri="{FF2B5EF4-FFF2-40B4-BE49-F238E27FC236}">
-                <a16:creationId xmlns:a16="http://schemas.microsoft.com/office/drawing/2014/main" id="{5D9734D4-0D88-405D-909B-6C4763BB9F5C}"/>
+                <a16:creationId xmlns:a16="http://schemas.microsoft.com/office/drawing/2014/main" id="{FE893D5B-0F91-452C-BB9D-021E8B9FD1A1}"/>
               </a:ext>
             </a:extLst>
           </p:cNvPr>
@@ -3637,7 +3637,7 @@
           <p:cNvPr id="3" name="">
             <a:extLst xmlns:a="http://schemas.openxmlformats.org/drawingml/2006/main">
               <a:ext uri="{FF2B5EF4-FFF2-40B4-BE49-F238E27FC236}">
-                <a16:creationId xmlns:a16="http://schemas.microsoft.com/office/drawing/2014/main" id="{0EC58DC0-A951-4706-9F6F-A51377D7FA03}"/>
+                <a16:creationId xmlns:a16="http://schemas.microsoft.com/office/drawing/2014/main" id="{A6BDA3FA-E5BC-4A0B-A678-16D4560F3CC2}"/>
               </a:ext>
             </a:extLst>
           </p:cNvPr>
@@ -3694,7 +3694,7 @@
           <p:cNvPr id="4" name="">
             <a:extLst xmlns:a="http://schemas.openxmlformats.org/drawingml/2006/main">
               <a:ext uri="{FF2B5EF4-FFF2-40B4-BE49-F238E27FC236}">
-                <a16:creationId xmlns:a16="http://schemas.microsoft.com/office/drawing/2014/main" id="{E977407D-3F05-4841-98E9-24DA696E1D87}"/>
+                <a16:creationId xmlns:a16="http://schemas.microsoft.com/office/drawing/2014/main" id="{FED546F0-DB08-4911-8A55-1AB9A7489911}"/>
               </a:ext>
             </a:extLst>
           </p:cNvPr>
@@ -3751,7 +3751,7 @@
           <p:cNvPr id="5" name="">
             <a:extLst xmlns:a="http://schemas.openxmlformats.org/drawingml/2006/main">
               <a:ext uri="{FF2B5EF4-FFF2-40B4-BE49-F238E27FC236}">
-                <a16:creationId xmlns:a16="http://schemas.microsoft.com/office/drawing/2014/main" id="{86032F0F-833C-4B1A-8021-046D3E43B3B0}"/>
+                <a16:creationId xmlns:a16="http://schemas.microsoft.com/office/drawing/2014/main" id="{06026B54-3CD6-4329-AF47-C0BF89E286A9}"/>
               </a:ext>
             </a:extLst>
           </p:cNvPr>
@@ -3808,7 +3808,7 @@
           <p:cNvPr id="6" name="">
             <a:extLst xmlns:a="http://schemas.openxmlformats.org/drawingml/2006/main">
               <a:ext uri="{FF2B5EF4-FFF2-40B4-BE49-F238E27FC236}">
-                <a16:creationId xmlns:a16="http://schemas.microsoft.com/office/drawing/2014/main" id="{5C29D187-0ED9-4E4F-BA61-C6B49ACB2BE5}"/>
+                <a16:creationId xmlns:a16="http://schemas.microsoft.com/office/drawing/2014/main" id="{37E92B62-A425-4F87-BBC5-DB80F3949587}"/>
               </a:ext>
             </a:extLst>
           </p:cNvPr>
@@ -3865,7 +3865,7 @@
           <p:cNvPr id="7" name="">
             <a:extLst xmlns:a="http://schemas.openxmlformats.org/drawingml/2006/main">
               <a:ext uri="{FF2B5EF4-FFF2-40B4-BE49-F238E27FC236}">
-                <a16:creationId xmlns:a16="http://schemas.microsoft.com/office/drawing/2014/main" id="{C3CC9FDC-C9E6-4A7F-BAE3-3E1ED04C1AC8}"/>
+                <a16:creationId xmlns:a16="http://schemas.microsoft.com/office/drawing/2014/main" id="{EEDB19D8-1CDC-4EA4-8ED2-E57462BB7786}"/>
               </a:ext>
             </a:extLst>
           </p:cNvPr>
@@ -3945,7 +3945,7 @@
           <p:cNvPr id="8" name="">
             <a:extLst xmlns:a="http://schemas.openxmlformats.org/drawingml/2006/main">
               <a:ext uri="{FF2B5EF4-FFF2-40B4-BE49-F238E27FC236}">
-                <a16:creationId xmlns:a16="http://schemas.microsoft.com/office/drawing/2014/main" id="{AC1505A7-01AD-4E42-884D-54F9B82623C3}"/>
+                <a16:creationId xmlns:a16="http://schemas.microsoft.com/office/drawing/2014/main" id="{4BC5143D-1CED-4337-A261-57A77CBB583B}"/>
               </a:ext>
             </a:extLst>
           </p:cNvPr>
@@ -4000,7 +4000,7 @@
     </p:spTree>
     <p:extLst>
       <p:ext uri="{BB962C8B-B14F-4D97-AF65-F5344CB8AC3E}">
-        <p14:creationId xmlns:p14="http://schemas.microsoft.com/office/powerpoint/2010/main" val="1856455439"/>
+        <p14:creationId xmlns:p14="http://schemas.microsoft.com/office/powerpoint/2010/main" val="1239559126"/>
       </p:ext>
     </p:extLst>
   </p:cSld>
@@ -4031,7 +4031,7 @@
           <p:cNvPr id="8" name="">
             <a:extLst xmlns:a="http://schemas.openxmlformats.org/drawingml/2006/main">
               <a:ext uri="{FF2B5EF4-FFF2-40B4-BE49-F238E27FC236}">
-                <a16:creationId xmlns:a16="http://schemas.microsoft.com/office/drawing/2014/main" id="{F2B3CA66-2E4E-4DC2-B00C-29BF9146FBDD}"/>
+                <a16:creationId xmlns:a16="http://schemas.microsoft.com/office/drawing/2014/main" id="{27E29254-E4E3-4B47-A7C7-87488BBB9A12}"/>
               </a:ext>
             </a:extLst>
           </p:cNvPr>
@@ -4088,7 +4088,7 @@
           <p:cNvPr id="2" name="">
             <a:extLst xmlns:a="http://schemas.openxmlformats.org/drawingml/2006/main">
               <a:ext uri="{FF2B5EF4-FFF2-40B4-BE49-F238E27FC236}">
-                <a16:creationId xmlns:a16="http://schemas.microsoft.com/office/drawing/2014/main" id="{0AB692DD-B4FE-4CFE-AFB2-ADD08F9FFD01}"/>
+                <a16:creationId xmlns:a16="http://schemas.microsoft.com/office/drawing/2014/main" id="{23D1309E-DE4C-46D9-AADC-33C241EBA1A4}"/>
               </a:ext>
             </a:extLst>
           </p:cNvPr>
@@ -4145,7 +4145,7 @@
           <p:cNvPr id="3" name="">
             <a:extLst xmlns:a="http://schemas.openxmlformats.org/drawingml/2006/main">
               <a:ext uri="{FF2B5EF4-FFF2-40B4-BE49-F238E27FC236}">
-                <a16:creationId xmlns:a16="http://schemas.microsoft.com/office/drawing/2014/main" id="{C4B14587-8E1F-4A3F-985D-AD86B4DA4B9A}"/>
+                <a16:creationId xmlns:a16="http://schemas.microsoft.com/office/drawing/2014/main" id="{0FDB7EDB-F9C5-4432-9701-5850C762D2C0}"/>
               </a:ext>
             </a:extLst>
           </p:cNvPr>
@@ -4202,7 +4202,7 @@
           <p:cNvPr id="4" name="">
             <a:extLst xmlns:a="http://schemas.openxmlformats.org/drawingml/2006/main">
               <a:ext uri="{FF2B5EF4-FFF2-40B4-BE49-F238E27FC236}">
-                <a16:creationId xmlns:a16="http://schemas.microsoft.com/office/drawing/2014/main" id="{EA56FFAA-8526-43DB-AF5B-1FD5812998E8}"/>
+                <a16:creationId xmlns:a16="http://schemas.microsoft.com/office/drawing/2014/main" id="{5FAC85CA-6403-4652-B332-6EB2D32F197E}"/>
               </a:ext>
             </a:extLst>
           </p:cNvPr>
@@ -4259,7 +4259,7 @@
           <p:cNvPr id="5" name="">
             <a:extLst xmlns:a="http://schemas.openxmlformats.org/drawingml/2006/main">
               <a:ext uri="{FF2B5EF4-FFF2-40B4-BE49-F238E27FC236}">
-                <a16:creationId xmlns:a16="http://schemas.microsoft.com/office/drawing/2014/main" id="{EC145B65-EE75-4E19-A5B8-D327A2469A68}"/>
+                <a16:creationId xmlns:a16="http://schemas.microsoft.com/office/drawing/2014/main" id="{295D73E2-87A7-44EF-8988-72689024CA9A}"/>
               </a:ext>
             </a:extLst>
           </p:cNvPr>
@@ -4339,7 +4339,7 @@
           <p:cNvPr id="6" name="">
             <a:extLst xmlns:a="http://schemas.openxmlformats.org/drawingml/2006/main">
               <a:ext uri="{FF2B5EF4-FFF2-40B4-BE49-F238E27FC236}">
-                <a16:creationId xmlns:a16="http://schemas.microsoft.com/office/drawing/2014/main" id="{0D2A317A-9B79-472E-908A-302BA4964819}"/>
+                <a16:creationId xmlns:a16="http://schemas.microsoft.com/office/drawing/2014/main" id="{BE265C01-8868-4F20-B0C0-3F9A74DB05A6}"/>
               </a:ext>
             </a:extLst>
           </p:cNvPr>
@@ -4396,7 +4396,7 @@
           <p:cNvPr id="7" name="">
             <a:extLst xmlns:a="http://schemas.openxmlformats.org/drawingml/2006/main">
               <a:ext uri="{FF2B5EF4-FFF2-40B4-BE49-F238E27FC236}">
-                <a16:creationId xmlns:a16="http://schemas.microsoft.com/office/drawing/2014/main" id="{4AE24701-F336-4285-AAFE-44FF30CA9EC6}"/>
+                <a16:creationId xmlns:a16="http://schemas.microsoft.com/office/drawing/2014/main" id="{2BDBBF02-1C2A-424A-8943-2459D10ECA22}"/>
               </a:ext>
             </a:extLst>
           </p:cNvPr>
@@ -4497,7 +4497,7 @@
     </p:spTree>
     <p:extLst>
       <p:ext uri="{BB962C8B-B14F-4D97-AF65-F5344CB8AC3E}">
-        <p14:creationId xmlns:p14="http://schemas.microsoft.com/office/powerpoint/2010/main" val="216470015"/>
+        <p14:creationId xmlns:p14="http://schemas.microsoft.com/office/powerpoint/2010/main" val="297719226"/>
       </p:ext>
     </p:extLst>
   </p:cSld>
@@ -4528,7 +4528,7 @@
           <p:cNvPr id="12" name="">
             <a:extLst xmlns:a="http://schemas.openxmlformats.org/drawingml/2006/main">
               <a:ext uri="{FF2B5EF4-FFF2-40B4-BE49-F238E27FC236}">
-                <a16:creationId xmlns:a16="http://schemas.microsoft.com/office/drawing/2014/main" id="{1BBDC999-BCDE-4DE8-8325-B39B1EF3F884}"/>
+                <a16:creationId xmlns:a16="http://schemas.microsoft.com/office/drawing/2014/main" id="{BE41E533-4759-4265-B3FD-12EF1F8BA2FD}"/>
               </a:ext>
             </a:extLst>
           </p:cNvPr>
@@ -4585,7 +4585,7 @@
           <p:cNvPr id="2" name="">
             <a:extLst xmlns:a="http://schemas.openxmlformats.org/drawingml/2006/main">
               <a:ext uri="{FF2B5EF4-FFF2-40B4-BE49-F238E27FC236}">
-                <a16:creationId xmlns:a16="http://schemas.microsoft.com/office/drawing/2014/main" id="{04659BA4-93F5-476E-82F9-603267EBCFC1}"/>
+                <a16:creationId xmlns:a16="http://schemas.microsoft.com/office/drawing/2014/main" id="{91D02BB0-E90E-47A0-8856-551BC5902FEB}"/>
               </a:ext>
             </a:extLst>
           </p:cNvPr>
@@ -4642,7 +4642,7 @@
           <p:cNvPr id="3" name="">
             <a:extLst xmlns:a="http://schemas.openxmlformats.org/drawingml/2006/main">
               <a:ext uri="{FF2B5EF4-FFF2-40B4-BE49-F238E27FC236}">
-                <a16:creationId xmlns:a16="http://schemas.microsoft.com/office/drawing/2014/main" id="{25806096-1854-4933-9618-F21B52851B0D}"/>
+                <a16:creationId xmlns:a16="http://schemas.microsoft.com/office/drawing/2014/main" id="{D061CE63-C4F3-429A-8344-CDAEC05A20C0}"/>
               </a:ext>
             </a:extLst>
           </p:cNvPr>
@@ -4699,7 +4699,7 @@
           <p:cNvPr id="4" name="">
             <a:extLst xmlns:a="http://schemas.openxmlformats.org/drawingml/2006/main">
               <a:ext uri="{FF2B5EF4-FFF2-40B4-BE49-F238E27FC236}">
-                <a16:creationId xmlns:a16="http://schemas.microsoft.com/office/drawing/2014/main" id="{4346E3A6-3314-42DE-BEB6-58EB8CCECB45}"/>
+                <a16:creationId xmlns:a16="http://schemas.microsoft.com/office/drawing/2014/main" id="{5E22F8E3-5279-4317-B4CF-26B113FA669B}"/>
               </a:ext>
             </a:extLst>
           </p:cNvPr>
@@ -4756,7 +4756,7 @@
           <p:cNvPr id="5" name="">
             <a:extLst xmlns:a="http://schemas.openxmlformats.org/drawingml/2006/main">
               <a:ext uri="{FF2B5EF4-FFF2-40B4-BE49-F238E27FC236}">
-                <a16:creationId xmlns:a16="http://schemas.microsoft.com/office/drawing/2014/main" id="{F4CFEB77-55D4-4795-8988-B8FBA69FE6C1}"/>
+                <a16:creationId xmlns:a16="http://schemas.microsoft.com/office/drawing/2014/main" id="{55BFF807-C251-43C1-873B-B6664F497FEA}"/>
               </a:ext>
             </a:extLst>
           </p:cNvPr>
@@ -4813,7 +4813,7 @@
           <p:cNvPr id="6" name="">
             <a:extLst xmlns:a="http://schemas.openxmlformats.org/drawingml/2006/main">
               <a:ext uri="{FF2B5EF4-FFF2-40B4-BE49-F238E27FC236}">
-                <a16:creationId xmlns:a16="http://schemas.microsoft.com/office/drawing/2014/main" id="{DD94FE8F-0211-485D-B1CA-BE8F12E08A01}"/>
+                <a16:creationId xmlns:a16="http://schemas.microsoft.com/office/drawing/2014/main" id="{17CACE98-D911-4E74-B850-43C88B89C2A1}"/>
               </a:ext>
             </a:extLst>
           </p:cNvPr>
@@ -4870,7 +4870,7 @@
           <p:cNvPr id="7" name="">
             <a:extLst xmlns:a="http://schemas.openxmlformats.org/drawingml/2006/main">
               <a:ext uri="{FF2B5EF4-FFF2-40B4-BE49-F238E27FC236}">
-                <a16:creationId xmlns:a16="http://schemas.microsoft.com/office/drawing/2014/main" id="{1CA17F1D-AB0D-49AA-B983-33569CD62A6B}"/>
+                <a16:creationId xmlns:a16="http://schemas.microsoft.com/office/drawing/2014/main" id="{8FA8C2CB-7524-40D3-A447-7396273CD14E}"/>
               </a:ext>
             </a:extLst>
           </p:cNvPr>
@@ -4950,7 +4950,7 @@
           <p:cNvPr id="8" name="">
             <a:extLst xmlns:a="http://schemas.openxmlformats.org/drawingml/2006/main">
               <a:ext uri="{FF2B5EF4-FFF2-40B4-BE49-F238E27FC236}">
-                <a16:creationId xmlns:a16="http://schemas.microsoft.com/office/drawing/2014/main" id="{19E7AAF8-8D60-45C2-BF91-FB1C6E054A31}"/>
+                <a16:creationId xmlns:a16="http://schemas.microsoft.com/office/drawing/2014/main" id="{3CECC11F-F520-4D9B-9949-ECDC03DFD4B7}"/>
               </a:ext>
             </a:extLst>
           </p:cNvPr>
@@ -5007,7 +5007,7 @@
           <p:cNvPr id="9" name="">
             <a:extLst xmlns:a="http://schemas.openxmlformats.org/drawingml/2006/main">
               <a:ext uri="{FF2B5EF4-FFF2-40B4-BE49-F238E27FC236}">
-                <a16:creationId xmlns:a16="http://schemas.microsoft.com/office/drawing/2014/main" id="{434147A7-017F-4A0B-AE47-C3C09FBC3CD1}"/>
+                <a16:creationId xmlns:a16="http://schemas.microsoft.com/office/drawing/2014/main" id="{67971D74-B6ED-4701-B3CB-9BFD828B58B9}"/>
               </a:ext>
             </a:extLst>
           </p:cNvPr>
@@ -5110,7 +5110,7 @@
           <p:cNvPr id="10" name="">
             <a:extLst xmlns:a="http://schemas.openxmlformats.org/drawingml/2006/main">
               <a:ext uri="{FF2B5EF4-FFF2-40B4-BE49-F238E27FC236}">
-                <a16:creationId xmlns:a16="http://schemas.microsoft.com/office/drawing/2014/main" id="{EBCC2E6F-A2BE-48A8-95D0-88B91AD9C5A8}"/>
+                <a16:creationId xmlns:a16="http://schemas.microsoft.com/office/drawing/2014/main" id="{5D9ECEA8-81AD-47C4-9655-B057C8DB16B2}"/>
               </a:ext>
             </a:extLst>
           </p:cNvPr>
@@ -5167,7 +5167,7 @@
           <p:cNvPr id="11" name="">
             <a:extLst xmlns:a="http://schemas.openxmlformats.org/drawingml/2006/main">
               <a:ext uri="{FF2B5EF4-FFF2-40B4-BE49-F238E27FC236}">
-                <a16:creationId xmlns:a16="http://schemas.microsoft.com/office/drawing/2014/main" id="{8A470DB0-5417-4E98-BB48-4CCD3E629B5F}"/>
+                <a16:creationId xmlns:a16="http://schemas.microsoft.com/office/drawing/2014/main" id="{0A1ECA86-ED78-4507-9F4F-078647FFE801}"/>
               </a:ext>
             </a:extLst>
           </p:cNvPr>
@@ -5268,7 +5268,7 @@
     </p:spTree>
     <p:extLst>
       <p:ext uri="{BB962C8B-B14F-4D97-AF65-F5344CB8AC3E}">
-        <p14:creationId xmlns:p14="http://schemas.microsoft.com/office/powerpoint/2010/main" val="1509746806"/>
+        <p14:creationId xmlns:p14="http://schemas.microsoft.com/office/powerpoint/2010/main" val="828163793"/>
       </p:ext>
     </p:extLst>
   </p:cSld>
@@ -5299,7 +5299,7 @@
           <p:cNvPr id="9" name="">
             <a:extLst xmlns:a="http://schemas.openxmlformats.org/drawingml/2006/main">
               <a:ext uri="{FF2B5EF4-FFF2-40B4-BE49-F238E27FC236}">
-                <a16:creationId xmlns:a16="http://schemas.microsoft.com/office/drawing/2014/main" id="{611AFE28-B4EC-4ABD-A494-511916FE4053}"/>
+                <a16:creationId xmlns:a16="http://schemas.microsoft.com/office/drawing/2014/main" id="{E5CBE4B3-113C-4F4F-8C90-DE1DD451BB3B}"/>
               </a:ext>
             </a:extLst>
           </p:cNvPr>
@@ -5356,7 +5356,7 @@
           <p:cNvPr id="2" name="">
             <a:extLst xmlns:a="http://schemas.openxmlformats.org/drawingml/2006/main">
               <a:ext uri="{FF2B5EF4-FFF2-40B4-BE49-F238E27FC236}">
-                <a16:creationId xmlns:a16="http://schemas.microsoft.com/office/drawing/2014/main" id="{60531DD0-BB61-44C3-BBDF-F047271A485D}"/>
+                <a16:creationId xmlns:a16="http://schemas.microsoft.com/office/drawing/2014/main" id="{6B541900-99BD-4868-8139-F10FE11A35D3}"/>
               </a:ext>
             </a:extLst>
           </p:cNvPr>
@@ -5413,7 +5413,7 @@
           <p:cNvPr id="3" name="">
             <a:extLst xmlns:a="http://schemas.openxmlformats.org/drawingml/2006/main">
               <a:ext uri="{FF2B5EF4-FFF2-40B4-BE49-F238E27FC236}">
-                <a16:creationId xmlns:a16="http://schemas.microsoft.com/office/drawing/2014/main" id="{FCB321C1-FCFE-4DD2-872D-194A5BCB4028}"/>
+                <a16:creationId xmlns:a16="http://schemas.microsoft.com/office/drawing/2014/main" id="{6672ECE4-8415-4843-9C90-13181815E964}"/>
               </a:ext>
             </a:extLst>
           </p:cNvPr>
@@ -5470,7 +5470,7 @@
           <p:cNvPr id="4" name="">
             <a:extLst xmlns:a="http://schemas.openxmlformats.org/drawingml/2006/main">
               <a:ext uri="{FF2B5EF4-FFF2-40B4-BE49-F238E27FC236}">
-                <a16:creationId xmlns:a16="http://schemas.microsoft.com/office/drawing/2014/main" id="{268165EB-2D51-40A4-8BC1-5E1A7A432878}"/>
+                <a16:creationId xmlns:a16="http://schemas.microsoft.com/office/drawing/2014/main" id="{AD2E5D8F-C74D-4231-B3AE-668E03A47348}"/>
               </a:ext>
             </a:extLst>
           </p:cNvPr>
@@ -5527,7 +5527,7 @@
           <p:cNvPr id="5" name="">
             <a:extLst xmlns:a="http://schemas.openxmlformats.org/drawingml/2006/main">
               <a:ext uri="{FF2B5EF4-FFF2-40B4-BE49-F238E27FC236}">
-                <a16:creationId xmlns:a16="http://schemas.microsoft.com/office/drawing/2014/main" id="{03DE7409-3D25-4BAA-B4B6-9CEF919BAD27}"/>
+                <a16:creationId xmlns:a16="http://schemas.microsoft.com/office/drawing/2014/main" id="{343C48EA-671F-4EDE-B7DE-81CD9F9D0983}"/>
               </a:ext>
             </a:extLst>
           </p:cNvPr>
@@ -5584,7 +5584,7 @@
           <p:cNvPr id="6" name="">
             <a:extLst xmlns:a="http://schemas.openxmlformats.org/drawingml/2006/main">
               <a:ext uri="{FF2B5EF4-FFF2-40B4-BE49-F238E27FC236}">
-                <a16:creationId xmlns:a16="http://schemas.microsoft.com/office/drawing/2014/main" id="{FA6E674B-8B23-469A-866C-575CCB9BB486}"/>
+                <a16:creationId xmlns:a16="http://schemas.microsoft.com/office/drawing/2014/main" id="{294BB981-5889-4C26-8420-77DF16E2E81C}"/>
               </a:ext>
             </a:extLst>
           </p:cNvPr>
@@ -5664,7 +5664,7 @@
           <p:cNvPr id="7" name="">
             <a:extLst xmlns:a="http://schemas.openxmlformats.org/drawingml/2006/main">
               <a:ext uri="{FF2B5EF4-FFF2-40B4-BE49-F238E27FC236}">
-                <a16:creationId xmlns:a16="http://schemas.microsoft.com/office/drawing/2014/main" id="{A84ECA12-65EE-43C1-B906-0E082F1F23C1}"/>
+                <a16:creationId xmlns:a16="http://schemas.microsoft.com/office/drawing/2014/main" id="{8D560F37-795D-414C-9E17-961E0C69E2A6}"/>
               </a:ext>
             </a:extLst>
           </p:cNvPr>
@@ -5721,7 +5721,7 @@
           <p:cNvPr id="8" name="">
             <a:extLst xmlns:a="http://schemas.openxmlformats.org/drawingml/2006/main">
               <a:ext uri="{FF2B5EF4-FFF2-40B4-BE49-F238E27FC236}">
-                <a16:creationId xmlns:a16="http://schemas.microsoft.com/office/drawing/2014/main" id="{960DFE9C-6D30-424C-8A95-AE400DBE3BFE}"/>
+                <a16:creationId xmlns:a16="http://schemas.microsoft.com/office/drawing/2014/main" id="{E1CE2C06-7509-44BB-ABC6-4FC713885239}"/>
               </a:ext>
             </a:extLst>
           </p:cNvPr>
@@ -5776,7 +5776,7 @@
     </p:spTree>
     <p:extLst>
       <p:ext uri="{BB962C8B-B14F-4D97-AF65-F5344CB8AC3E}">
-        <p14:creationId xmlns:p14="http://schemas.microsoft.com/office/powerpoint/2010/main" val="272987018"/>
+        <p14:creationId xmlns:p14="http://schemas.microsoft.com/office/powerpoint/2010/main" val="1360428515"/>
       </p:ext>
     </p:extLst>
   </p:cSld>
@@ -5807,7 +5807,7 @@
           <p:cNvPr id="6" name="">
             <a:extLst xmlns:a="http://schemas.openxmlformats.org/drawingml/2006/main">
               <a:ext uri="{FF2B5EF4-FFF2-40B4-BE49-F238E27FC236}">
-                <a16:creationId xmlns:a16="http://schemas.microsoft.com/office/drawing/2014/main" id="{3A1E52A7-837B-4605-823E-C2F9F59070FA}"/>
+                <a16:creationId xmlns:a16="http://schemas.microsoft.com/office/drawing/2014/main" id="{A0C37042-A507-4396-86B1-80E8AEF54428}"/>
               </a:ext>
             </a:extLst>
           </p:cNvPr>
@@ -5864,7 +5864,7 @@
           <p:cNvPr id="2" name="">
             <a:extLst xmlns:a="http://schemas.openxmlformats.org/drawingml/2006/main">
               <a:ext uri="{FF2B5EF4-FFF2-40B4-BE49-F238E27FC236}">
-                <a16:creationId xmlns:a16="http://schemas.microsoft.com/office/drawing/2014/main" id="{A0279BC0-2BAE-41C0-A3A5-AD4679028538}"/>
+                <a16:creationId xmlns:a16="http://schemas.microsoft.com/office/drawing/2014/main" id="{FF1F2B99-9FD7-4C61-929D-019F13352070}"/>
               </a:ext>
             </a:extLst>
           </p:cNvPr>
@@ -5921,7 +5921,7 @@
           <p:cNvPr id="3" name="">
             <a:extLst xmlns:a="http://schemas.openxmlformats.org/drawingml/2006/main">
               <a:ext uri="{FF2B5EF4-FFF2-40B4-BE49-F238E27FC236}">
-                <a16:creationId xmlns:a16="http://schemas.microsoft.com/office/drawing/2014/main" id="{E068C567-6AC3-4824-AC37-3EC0230AB499}"/>
+                <a16:creationId xmlns:a16="http://schemas.microsoft.com/office/drawing/2014/main" id="{48B25814-6DEC-4EE2-AC6F-15BCA11BA71A}"/>
               </a:ext>
             </a:extLst>
           </p:cNvPr>
@@ -6024,7 +6024,7 @@
           <p:cNvPr id="4" name="">
             <a:extLst xmlns:a="http://schemas.openxmlformats.org/drawingml/2006/main">
               <a:ext uri="{FF2B5EF4-FFF2-40B4-BE49-F238E27FC236}">
-                <a16:creationId xmlns:a16="http://schemas.microsoft.com/office/drawing/2014/main" id="{A6232EF7-62A4-4938-A396-308AA86876B2}"/>
+                <a16:creationId xmlns:a16="http://schemas.microsoft.com/office/drawing/2014/main" id="{2313714D-5DCF-4503-A323-1AB462986FF8}"/>
               </a:ext>
             </a:extLst>
           </p:cNvPr>
@@ -6081,7 +6081,7 @@
           <p:cNvPr id="5" name="">
             <a:extLst xmlns:a="http://schemas.openxmlformats.org/drawingml/2006/main">
               <a:ext uri="{FF2B5EF4-FFF2-40B4-BE49-F238E27FC236}">
-                <a16:creationId xmlns:a16="http://schemas.microsoft.com/office/drawing/2014/main" id="{B7880FF2-DC0D-4186-9905-3909823ADD49}"/>
+                <a16:creationId xmlns:a16="http://schemas.microsoft.com/office/drawing/2014/main" id="{DD0997E7-FBF8-47DD-9C27-ED9B5B7141B9}"/>
               </a:ext>
             </a:extLst>
           </p:cNvPr>
@@ -6136,7 +6136,7 @@
     </p:spTree>
     <p:extLst>
       <p:ext uri="{BB962C8B-B14F-4D97-AF65-F5344CB8AC3E}">
-        <p14:creationId xmlns:p14="http://schemas.microsoft.com/office/powerpoint/2010/main" val="1402671923"/>
+        <p14:creationId xmlns:p14="http://schemas.microsoft.com/office/powerpoint/2010/main" val="314994404"/>
       </p:ext>
     </p:extLst>
   </p:cSld>

</xml_diff>